<commit_message>
Fix preview chart labels, add deck disclaimer, source housing-demand figure, fix RTL numbers
</commit_message>
<xml_diff>
--- a/repi_executive_deck.pptx
+++ b/repi_executive_deck.pptx
@@ -5995,6 +5995,60 @@
           </a:p>
         </p:txBody>
       </p:sp>
+      <p:sp>
+        <p:nvSpPr>
+          <p:cNvPr id="9" name="Disclaimer"/>
+          <p:cNvSpPr txBox="1"/>
+          <p:nvPr/>
+        </p:nvSpPr>
+        <p:spPr>
+          <a:xfrm>
+            <a:off x="640080" y="5669280"/>
+            <a:ext cx="10881360" cy="548640"/>
+          </a:xfrm>
+          <a:prstGeom prst="rect">
+            <a:avLst/>
+          </a:prstGeom>
+          <a:noFill/>
+          <a:ln/>
+        </p:spPr>
+        <p:txBody>
+          <a:bodyPr wrap="square" rtlCol="0" anchor="b"/>
+          <a:lstStyle/>
+          <a:p>
+            <a:pPr marL="0" indent="0" algn="r" rtl="1">
+              <a:buNone/>
+            </a:pPr>
+            <a:r>
+              <a:rPr lang="ar-SA" sz="1000" dirty="0">
+                <a:solidFill>
+                  <a:srgbClr val="8E97AC"/>
+                </a:solidFill>
+                <a:latin typeface="HelveticaNeueLT Arabic 55 Roman" panose="020B0604020202020204" pitchFamily="34" charset="-78"/>
+                <a:ea typeface="Arial" pitchFamily="34" charset="-122"/>
+                <a:cs typeface="HelveticaNeueLT Arabic 55 Roman" panose="020B0604020202020204" pitchFamily="34" charset="-78"/>
+              </a:rPr>
+              <a:t>مشروع شخصي مبني على بيانات عامة فقط، ولا يمثّل رأي أي جهة عمل، وليس نصيحة استثمارية.</a:t>
+            </a:r>
+          </a:p>
+          <a:p>
+            <a:pPr marL="0" indent="0" algn="r" rtl="0">
+              <a:buNone/>
+            </a:pPr>
+            <a:r>
+              <a:rPr lang="en-US" sz="1000" dirty="0">
+                <a:solidFill>
+                  <a:srgbClr val="8E97AC"/>
+                </a:solidFill>
+                <a:latin typeface="HelveticaNeueLT Arabic 55 Roman" panose="020B0604020202020204" pitchFamily="34" charset="-78"/>
+                <a:ea typeface="Arial" pitchFamily="34" charset="-122"/>
+                <a:cs typeface="HelveticaNeueLT Arabic 55 Roman" panose="020B0604020202020204" pitchFamily="34" charset="-78"/>
+              </a:rPr>
+              <a:t>Personal project using public data only. Not the view of any employer. Not investment advice.</a:t>
+            </a:r>
+          </a:p>
+        </p:txBody>
+      </p:sp>
     </p:spTree>
   </p:cSld>
   <p:clrMapOvr>
@@ -7202,7 +7256,7 @@
                 <a:ea typeface="Cambria" pitchFamily="34" charset="-122"/>
                 <a:cs typeface="HelveticaNeueLT Arabic 55 Roman" panose="020B0604020202020204" pitchFamily="34" charset="-78"/>
               </a:rPr>
-              <a:t>800K+</a:t>
+              <a:t>825K</a:t>
             </a:r>
             <a:endParaRPr lang="en-US" sz="2600" dirty="0">
               <a:latin typeface="HelveticaNeueLT Arabic 55 Roman" panose="020B0604020202020204" pitchFamily="34" charset="-78"/>
@@ -7247,7 +7301,7 @@
                 <a:ea typeface="Arial" pitchFamily="34" charset="-122"/>
                 <a:cs typeface="HelveticaNeueLT Arabic 55 Roman" panose="020B0604020202020204" pitchFamily="34" charset="-78"/>
               </a:rPr>
-              <a:t>عجز سكني تراكمي متوقع</a:t>
+              <a:t>طلب سكني متوقع (وحدة)</a:t>
             </a:r>
             <a:endParaRPr lang="en-US" sz="1200" dirty="0">
               <a:latin typeface="HelveticaNeueLT Arabic 55 Roman" panose="020B0604020202020204" pitchFamily="34" charset="-78"/>
@@ -7270,7 +7324,7 @@
                 <a:ea typeface="Arial" pitchFamily="34" charset="-122"/>
                 <a:cs typeface="HelveticaNeueLT Arabic 55 Roman" panose="020B0604020202020204" pitchFamily="34" charset="-78"/>
               </a:rPr>
-              <a:t>بحلول 2030</a:t>
+              <a:t>من 2024 إلى 2030</a:t>
             </a:r>
             <a:endParaRPr lang="en-US" sz="1200" dirty="0">
               <a:latin typeface="HelveticaNeueLT Arabic 55 Roman" panose="020B0604020202020204" pitchFamily="34" charset="-78"/>
@@ -7312,7 +7366,7 @@
                 <a:ea typeface="Arial" pitchFamily="34" charset="-122"/>
                 <a:cs typeface="HelveticaNeueLT Arabic 55 Roman" panose="020B0604020202020204" pitchFamily="34" charset="-78"/>
               </a:rPr>
-              <a:t>تقارير قطاع الإسكان</a:t>
+              <a:t>Knight Frank، نوفمبر 2024</a:t>
             </a:r>
             <a:endParaRPr lang="en-US" sz="950" dirty="0">
               <a:latin typeface="HelveticaNeueLT Arabic 55 Roman" panose="020B0604020202020204" pitchFamily="34" charset="-78"/>
@@ -10893,7 +10947,7 @@
                 <a:ea typeface="Arial" pitchFamily="34" charset="-122"/>
                 <a:cs typeface="HelveticaNeueLT Arabic 55 Roman" panose="020B0604020202020204" pitchFamily="34" charset="-78"/>
               </a:rPr>
-              <a:t>فجوة سكنية تراكمية +800K وحدة بحلول 2030</a:t>
+              <a:t>طلب سكني متوقع نحو 825K وحدة حتى 2030 (Knight Frank)</a:t>
             </a:r>
             <a:endParaRPr lang="en-US" sz="1150" dirty="0">
               <a:latin typeface="HelveticaNeueLT Arabic 55 Roman" panose="020B0604020202020204" pitchFamily="34" charset="-78"/>

</xml_diff>